<commit_message>
Oppdatert med referanse til I2C_Host custom name
</commit_message>
<xml_diff>
--- a/Kursdag 3/Dag tre.pptx
+++ b/Kursdag 3/Dag tre.pptx
@@ -5593,7 +5593,9 @@
         </p:nvSpPr>
         <p:spPr/>
         <p:txBody>
-          <a:bodyPr/>
+          <a:bodyPr>
+            <a:normAutofit/>
+          </a:bodyPr>
           <a:lstStyle/>
           <a:p>
             <a:r>
@@ -5636,7 +5638,7 @@
             <a:pPr lvl="1"/>
             <a:r>
               <a:rPr lang="nb-NO" dirty="0"/>
-              <a:t>Endre navn til I2C-Host</a:t>
+              <a:t>Endre navn fra I2C0_Host til I2C_Host</a:t>
             </a:r>
           </a:p>
           <a:p>

</xml_diff>